<commit_message>
Refresh deck + memo with lipidomics (C18) cross-method result
- Deck: new 'Generalizes — lipidomics is the stronger case' slide (grouped-bar: HILIC vs lipid
  flagged% + null controls). Lipids 18.2% vs HILIC 9.9%, with tighter co-elution specificity.
- Memo: new lipidomics section (18.2% of 360k candidates; RP co-elution strongly discriminating;
  lipid-specific losses add only +0.6pp -> artifacts are mostly adducts/isotopes/small losses).

Co-Authored-By: Claude Opus 4.8 (1M context) <noreply@anthropic.com>
</commit_message>
<xml_diff>
--- a/reports/unconfirmed_deorphan_slides.pptx
+++ b/reports/unconfirmed_deorphan_slides.pptx
@@ -13,6 +13,7 @@
     <p:sldId id="261" r:id="rId12"/>
     <p:sldId id="262" r:id="rId13"/>
     <p:sldId id="263" r:id="rId14"/>
+    <p:sldId id="264" r:id="rId15"/>
   </p:sldIdLst>
   <p:sldSz cx="12191695" cy="6858000" type="screen4x3"/>
   <p:notesSz cx="6858000" cy="9144000"/>
@@ -3633,7 +3634,7 @@
                   <a:srgbClr val="FFFFFF"/>
                 </a:solidFill>
               </a:rPr>
-              <a:t>Result</a:t>
+              <a:t>Result — HILIC (polar metabolites)</a:t>
             </a:r>
           </a:p>
         </p:txBody>
@@ -3710,6 +3711,138 @@
 </file>
 
 <file path=ppt/slides/slide5.xml><?xml version="1.0" encoding="utf-8"?>
+<p:sld xmlns:a="http://schemas.openxmlformats.org/drawingml/2006/main" xmlns:p="http://schemas.openxmlformats.org/presentationml/2006/main" xmlns:r="http://schemas.openxmlformats.org/officeDocument/2006/relationships">
+  <p:cSld>
+    <p:spTree>
+      <p:nvGrpSpPr>
+        <p:cNvPr id="1" name=""/>
+        <p:cNvGrpSpPr/>
+        <p:nvPr/>
+      </p:nvGrpSpPr>
+      <p:grpSpPr/>
+      <p:sp>
+        <p:nvSpPr>
+          <p:cNvPr id="2" name="Rectangle 1"/>
+          <p:cNvSpPr/>
+          <p:nvPr/>
+        </p:nvSpPr>
+        <p:spPr>
+          <a:xfrm>
+            <a:off x="0" y="0"/>
+            <a:ext cx="12191695" cy="1051560"/>
+          </a:xfrm>
+          <a:prstGeom prst="rect">
+            <a:avLst/>
+          </a:prstGeom>
+          <a:solidFill>
+            <a:srgbClr val="1F2D3D"/>
+          </a:solidFill>
+          <a:ln>
+            <a:noFill/>
+          </a:ln>
+        </p:spPr>
+        <p:style>
+          <a:lnRef idx="1">
+            <a:schemeClr val="accent1"/>
+          </a:lnRef>
+          <a:fillRef idx="3">
+            <a:schemeClr val="accent1"/>
+          </a:fillRef>
+          <a:effectRef idx="2">
+            <a:schemeClr val="accent1"/>
+          </a:effectRef>
+          <a:fontRef idx="minor">
+            <a:schemeClr val="lt1"/>
+          </a:fontRef>
+        </p:style>
+        <p:txBody>
+          <a:bodyPr rtlCol="0" anchor="ctr" lIns="457200"/>
+          <a:lstStyle/>
+          <a:p>
+            <a:pPr algn="ctr"/>
+            <a:r>
+              <a:rPr sz="2600" b="1">
+                <a:solidFill>
+                  <a:srgbClr val="FFFFFF"/>
+                </a:solidFill>
+              </a:rPr>
+              <a:t>Generalizes — lipidomics (C18) is the stronger case</a:t>
+            </a:r>
+          </a:p>
+        </p:txBody>
+      </p:sp>
+      <p:pic>
+        <p:nvPicPr>
+          <p:cNvPr id="3" name="Picture 2" descr="crossmethod.png"/>
+          <p:cNvPicPr>
+            <a:picLocks noChangeAspect="1"/>
+          </p:cNvPicPr>
+          <p:nvPr/>
+        </p:nvPicPr>
+        <p:blipFill>
+          <a:blip r:embed="rId2"/>
+          <a:stretch>
+            <a:fillRect/>
+          </a:stretch>
+        </p:blipFill>
+        <p:spPr>
+          <a:xfrm>
+            <a:off x="1280160" y="1280160"/>
+            <a:ext cx="7864437" cy="4754880"/>
+          </a:xfrm>
+          <a:prstGeom prst="rect">
+            <a:avLst/>
+          </a:prstGeom>
+        </p:spPr>
+      </p:pic>
+      <p:sp>
+        <p:nvSpPr>
+          <p:cNvPr id="4" name="TextBox 3"/>
+          <p:cNvSpPr txBox="1"/>
+          <p:nvPr/>
+        </p:nvSpPr>
+        <p:spPr>
+          <a:xfrm>
+            <a:off x="640080" y="6126480"/>
+            <a:ext cx="10881360" cy="640080"/>
+          </a:xfrm>
+          <a:prstGeom prst="rect">
+            <a:avLst/>
+          </a:prstGeom>
+          <a:noFill/>
+        </p:spPr>
+        <p:txBody>
+          <a:bodyPr wrap="square">
+            <a:spAutoFit/>
+          </a:bodyPr>
+          <a:lstStyle/>
+          <a:p>
+            <a:pPr>
+              <a:spcAft>
+                <a:spcPts val="600"/>
+              </a:spcAft>
+            </a:pPr>
+            <a:r>
+              <a:rPr sz="1400" b="0">
+                <a:solidFill>
+                  <a:srgbClr val="5D6D7E"/>
+                </a:solidFill>
+                <a:latin typeface="Calibri"/>
+              </a:rPr>
+              <a:t>C18-neg: 18.2% of 360,231 candidates flagged (ISF 37k / ¹³C-isotope 20k / adduct 8k). Reverse-phase spreads lipids out, so co-elution is strongly discriminating (RI-shuffle 3.8% vs HILIC 7.6%). Examples: PE 18:0_18:2 −H₂O; PC/SM via acetate; FAHFA +Na. Lipid-specific acyl/headgroup losses add only +0.6 pp → artifacts are mostly adducts/isotopes/small losses.</a:t>
+            </a:r>
+          </a:p>
+        </p:txBody>
+      </p:sp>
+    </p:spTree>
+  </p:cSld>
+  <p:clrMapOvr>
+    <a:masterClrMapping/>
+  </p:clrMapOvr>
+</p:sld>
+</file>
+
+<file path=ppt/slides/slide6.xml><?xml version="1.0" encoding="utf-8"?>
 <p:sld xmlns:a="http://schemas.openxmlformats.org/drawingml/2006/main" xmlns:p="http://schemas.openxmlformats.org/presentationml/2006/main" xmlns:r="http://schemas.openxmlformats.org/officeDocument/2006/relationships">
   <p:cSld>
     <p:spTree>
@@ -4809,7 +4942,7 @@
 </p:sld>
 </file>
 
-<file path=ppt/slides/slide6.xml><?xml version="1.0" encoding="utf-8"?>
+<file path=ppt/slides/slide7.xml><?xml version="1.0" encoding="utf-8"?>
 <p:sld xmlns:a="http://schemas.openxmlformats.org/drawingml/2006/main" xmlns:p="http://schemas.openxmlformats.org/presentationml/2006/main" xmlns:r="http://schemas.openxmlformats.org/officeDocument/2006/relationships">
   <p:cSld>
     <p:spTree>
@@ -4941,7 +5074,7 @@
 </p:sld>
 </file>
 
-<file path=ppt/slides/slide7.xml><?xml version="1.0" encoding="utf-8"?>
+<file path=ppt/slides/slide8.xml><?xml version="1.0" encoding="utf-8"?>
 <p:sld xmlns:a="http://schemas.openxmlformats.org/drawingml/2006/main" xmlns:p="http://schemas.openxmlformats.org/presentationml/2006/main" xmlns:r="http://schemas.openxmlformats.org/officeDocument/2006/relationships">
   <p:cSld>
     <p:spTree>
@@ -5113,7 +5246,7 @@
 </p:sld>
 </file>
 
-<file path=ppt/slides/slide8.xml><?xml version="1.0" encoding="utf-8"?>
+<file path=ppt/slides/slide9.xml><?xml version="1.0" encoding="utf-8"?>
 <p:sld xmlns:a="http://schemas.openxmlformats.org/drawingml/2006/main" xmlns:p="http://schemas.openxmlformats.org/presentationml/2006/main" xmlns:r="http://schemas.openxmlformats.org/officeDocument/2006/relationships">
   <p:cSld>
     <p:spTree>

</xml_diff>

<commit_message>
Add C18-positive lipidomics result (10.2%, adduct-dominated) to deck + memo
C18-pos: 5,106/50,000 (10.2%) flagged, adduct-dominated (TG [M+NH4]+, PC [M+Na/K]+) vs C18-neg's
ISF-dominated 18.2% -> relation profile tracks ionization mode (validation). Cross-method fig now
3 methods (HILIC 9.9% / C18-neg 18.2% / C18-pos 10.2%) with dominant-relation labels. Runner accepts
{tag}_confirmed.csv as bins alias.

Co-Authored-By: Claude Opus 4.8 (1M context) <noreply@anthropic.com>
</commit_message>
<xml_diff>
--- a/reports/unconfirmed_deorphan_slides.pptx
+++ b/reports/unconfirmed_deorphan_slides.pptx
@@ -3766,7 +3766,7 @@
                   <a:srgbClr val="FFFFFF"/>
                 </a:solidFill>
               </a:rPr>
-              <a:t>Generalizes — lipidomics (C18) is the stronger case</a:t>
+              <a:t>Generalizes across methods — and tracks the chemistry</a:t>
             </a:r>
           </a:p>
         </p:txBody>
@@ -3788,7 +3788,7 @@
         <p:spPr>
           <a:xfrm>
             <a:off x="1280160" y="1280160"/>
-            <a:ext cx="7864437" cy="4754880"/>
+            <a:ext cx="8480140" cy="4754880"/>
           </a:xfrm>
           <a:prstGeom prst="rect">
             <a:avLst/>
@@ -3829,7 +3829,7 @@
                 </a:solidFill>
                 <a:latin typeface="Calibri"/>
               </a:rPr>
-              <a:t>C18-neg: 18.2% of 360,231 candidates flagged (ISF 37k / ¹³C-isotope 20k / adduct 8k). Reverse-phase spreads lipids out, so co-elution is strongly discriminating (RI-shuffle 3.8% vs HILIC 7.6%). Examples: PE 18:0_18:2 −H₂O; PC/SM via acetate; FAHFA +Na. Lipid-specific acyl/headgroup losses add only +0.6 pp → artifacts are mostly adducts/isotopes/small losses.</a:t>
+              <a:t>C18-neg 18.2% (ISF-dominated: water/CO₂/acetate); C18-pos 10.2% (ADDUCT-dominated: TG [M+NH₄]⁺, PC [M+Na/K]⁺ — exactly what positive-mode lipids form). RP co-elution is strongly discriminating both polarities (RI-shuffle 2–4% vs HILIC's 8%). The relation profile shifting neg→pos is itself a validation.</a:t>
             </a:r>
           </a:p>
         </p:txBody>

</xml_diff>